<commit_message>
launch of cover-to-cover clean-up
</commit_message>
<xml_diff>
--- a/figures/__figures-handmade.pptx
+++ b/figures/__figures-handmade.pptx
@@ -6,7 +6,8 @@
   </p:sldMasterIdLst>
   <p:sldIdLst>
     <p:sldId id="256" r:id="rId2"/>
-    <p:sldId id="257" r:id="rId3"/>
+    <p:sldId id="258" r:id="rId3"/>
+    <p:sldId id="257" r:id="rId4"/>
   </p:sldIdLst>
   <p:sldSz cx="12192000" cy="6858000"/>
   <p:notesSz cx="6858000" cy="9144000"/>
@@ -3342,7 +3343,7 @@
         <p:spPr>
           <a:xfrm>
             <a:off x="4238846" y="157010"/>
-            <a:ext cx="6096000" cy="2031325"/>
+            <a:ext cx="6096000" cy="6740307"/>
           </a:xfrm>
           <a:prstGeom prst="rect">
             <a:avLst/>
@@ -3354,6 +3355,46 @@
             <a:spAutoFit/>
           </a:bodyPr>
           <a:lstStyle/>
+          <a:p>
+            <a:pPr algn="l">
+              <a:buNone/>
+            </a:pPr>
+            <a:r>
+              <a:rPr lang="en-GB" i="1" dirty="0">
+                <a:solidFill>
+                  <a:srgbClr val="343A40"/>
+                </a:solidFill>
+                <a:latin typeface="Source Sans Pro" panose="020B0503030403020204" pitchFamily="34" charset="0"/>
+              </a:rPr>
+              <a:t>“The partnership between DECEA and EUROCONTROL continues to consolidate itself as a reference in international technical cooperation aimed at excellence in ATM performance management. The Performance Review Commission (PRC), in particular, has been a strategic partner in deepening comparative studies between Brazil and Europe, with ongoing support for data sharing, indicator analysis, and the adoption of best practices in performance management.</a:t>
+            </a:r>
+          </a:p>
+          <a:p>
+            <a:pPr algn="l">
+              <a:buNone/>
+            </a:pPr>
+            <a:r>
+              <a:rPr lang="en-GB" i="1" dirty="0">
+                <a:solidFill>
+                  <a:srgbClr val="343A40"/>
+                </a:solidFill>
+                <a:latin typeface="Source Sans Pro" panose="020B0503030403020204" pitchFamily="34" charset="0"/>
+              </a:rPr>
+              <a:t>This report reflects the results of that joint effort, which has expanded with each edition. The inclusion of new topics, such as the Point Merge, as well as the comparison related to the Curitiba and Lisbon ACCs, shows that even with distinct regional characteristics and operational specificities, benchmarking is not only possible but highly valuable. It broadens mutual understanding and reinforces the feasibility of applying solutions and concepts to the reality of each system.</a:t>
+            </a:r>
+          </a:p>
+          <a:p>
+            <a:pPr algn="l"/>
+            <a:r>
+              <a:rPr lang="en-GB" i="1" dirty="0">
+                <a:solidFill>
+                  <a:srgbClr val="343A40"/>
+                </a:solidFill>
+                <a:latin typeface="Source Sans Pro" panose="020B0503030403020204" pitchFamily="34" charset="0"/>
+              </a:rPr>
+              <a:t>This promising journey highlights the evolution of our air navigation system, driven by performance measurement and continuous dialogue with partners such as EUROCONTROL. It demonstrates that we are on the right path — one guided by cooperation, transparency, and a commitment to continuous improvement.</a:t>
+            </a:r>
+          </a:p>
           <a:p>
             <a:pPr algn="just"/>
             <a:r>
@@ -3364,7 +3405,7 @@
                 <a:effectLst/>
                 <a:latin typeface="Source Sans Pro" panose="020F0502020204030204" pitchFamily="34" charset="0"/>
               </a:rPr>
-              <a:t>“Our partnership with EUROCONTROL and the PRC is vital to fostering a joint understanding of the characteristics of both systems and how these relate to operational performance. The continual work on the Brazil-Europe comparison report is an essential enabler for Brazil to take stock of the improvements made within the Brazilian system and understand potential future constraints comparing the Brazilian context to Europe.”</a:t>
+              <a:t>”</a:t>
             </a:r>
             <a:endParaRPr lang="en-GB" i="1" dirty="0"/>
           </a:p>
@@ -3398,7 +3439,6 @@
           </a:bodyPr>
           <a:lstStyle/>
           <a:p>
-            <a:pPr algn="l"/>
             <a:r>
               <a:rPr lang="en-GB" b="1" i="0" dirty="0">
                 <a:solidFill>
@@ -3407,17 +3447,7 @@
                 <a:effectLst/>
                 <a:latin typeface="Source Sans Pro" panose="020B0503030403020204" pitchFamily="34" charset="0"/>
               </a:rPr>
-              <a:t>Brigadier </a:t>
-            </a:r>
-            <a:r>
-              <a:rPr lang="en-GB" b="1" i="0">
-                <a:solidFill>
-                  <a:srgbClr val="343A40"/>
-                </a:solidFill>
-                <a:effectLst/>
-                <a:latin typeface="Source Sans Pro" panose="020B0503030403020204" pitchFamily="34" charset="0"/>
-              </a:rPr>
-              <a:t>… Medeiros</a:t>
+              <a:t>General Maurício Augusto Silveira de Medeiros</a:t>
             </a:r>
             <a:endParaRPr lang="en-GB" b="0" i="0" dirty="0">
               <a:solidFill>
@@ -3470,7 +3500,7 @@
         </p:blipFill>
         <p:spPr>
           <a:xfrm>
-            <a:off x="8293101" y="3269512"/>
+            <a:off x="8293101" y="3805531"/>
             <a:ext cx="2041745" cy="2041745"/>
           </a:xfrm>
           <a:prstGeom prst="rect">
@@ -3492,7 +3522,7 @@
         </p:nvSpPr>
         <p:spPr>
           <a:xfrm>
-            <a:off x="1408043" y="3107897"/>
+            <a:off x="1408043" y="3643916"/>
             <a:ext cx="6545110" cy="2585323"/>
           </a:xfrm>
           <a:prstGeom prst="rect">
@@ -3552,7 +3582,7 @@
         </p:nvSpPr>
         <p:spPr>
           <a:xfrm>
-            <a:off x="4237074" y="5689782"/>
+            <a:off x="4237074" y="6225801"/>
             <a:ext cx="6097772" cy="646331"/>
           </a:xfrm>
           <a:prstGeom prst="rect">
@@ -3629,7 +3659,7 @@
         </p:blipFill>
         <p:spPr>
           <a:xfrm>
-            <a:off x="1639344" y="101511"/>
+            <a:off x="1597303" y="197276"/>
             <a:ext cx="2126537" cy="2126537"/>
           </a:xfrm>
           <a:prstGeom prst="rect">
@@ -3651,6 +3681,410 @@
 </file>
 
 <file path=ppt/slides/slide2.xml><?xml version="1.0" encoding="utf-8"?>
+<p:sld xmlns:a="http://schemas.openxmlformats.org/drawingml/2006/main" xmlns:r="http://schemas.openxmlformats.org/officeDocument/2006/relationships" xmlns:p="http://schemas.openxmlformats.org/presentationml/2006/main">
+  <p:cSld>
+    <p:spTree>
+      <p:nvGrpSpPr>
+        <p:cNvPr id="1" name=""/>
+        <p:cNvGrpSpPr/>
+        <p:nvPr/>
+      </p:nvGrpSpPr>
+      <p:grpSpPr>
+        <a:xfrm>
+          <a:off x="0" y="0"/>
+          <a:ext cx="0" cy="0"/>
+          <a:chOff x="0" y="0"/>
+          <a:chExt cx="0" cy="0"/>
+        </a:xfrm>
+      </p:grpSpPr>
+      <p:sp>
+        <p:nvSpPr>
+          <p:cNvPr id="3" name="TextBox 2">
+            <a:extLst>
+              <a:ext uri="{FF2B5EF4-FFF2-40B4-BE49-F238E27FC236}">
+                <a16:creationId xmlns:a16="http://schemas.microsoft.com/office/drawing/2014/main" id="{33C4B04A-CBDD-3040-7014-5B44E0594BCA}"/>
+              </a:ext>
+            </a:extLst>
+          </p:cNvPr>
+          <p:cNvSpPr txBox="1"/>
+          <p:nvPr/>
+        </p:nvSpPr>
+        <p:spPr>
+          <a:xfrm>
+            <a:off x="3279227" y="1134581"/>
+            <a:ext cx="7817224" cy="5355312"/>
+          </a:xfrm>
+          <a:prstGeom prst="rect">
+            <a:avLst/>
+          </a:prstGeom>
+          <a:noFill/>
+        </p:spPr>
+        <p:txBody>
+          <a:bodyPr wrap="square">
+            <a:spAutoFit/>
+          </a:bodyPr>
+          <a:lstStyle/>
+          <a:p>
+            <a:pPr algn="just">
+              <a:buNone/>
+            </a:pPr>
+            <a:r>
+              <a:rPr lang="en-GB" i="1" dirty="0">
+                <a:solidFill>
+                  <a:srgbClr val="343A40"/>
+                </a:solidFill>
+                <a:latin typeface="Source Sans Pro" panose="020B0503030403020204" pitchFamily="34" charset="0"/>
+              </a:rPr>
+              <a:t>The partnership between DECEA and EUROCONTROL continues to consolidate itself as a reference in international technical cooperation aimed at excellence in ATM performance management. The Performance Review Commission (PRC), in particular, has been a strategic partner in deepening comparative studies between Brazil and Europe, with ongoing support for data sharing, indicator analysis, and the adoption of best practices in performance management.</a:t>
+            </a:r>
+          </a:p>
+          <a:p>
+            <a:pPr algn="just">
+              <a:buNone/>
+            </a:pPr>
+            <a:endParaRPr lang="en-GB" i="1" dirty="0">
+              <a:solidFill>
+                <a:srgbClr val="343A40"/>
+              </a:solidFill>
+              <a:latin typeface="Source Sans Pro" panose="020B0503030403020204" pitchFamily="34" charset="0"/>
+            </a:endParaRPr>
+          </a:p>
+          <a:p>
+            <a:pPr algn="just">
+              <a:buNone/>
+            </a:pPr>
+            <a:r>
+              <a:rPr lang="en-GB" i="1" dirty="0">
+                <a:solidFill>
+                  <a:srgbClr val="343A40"/>
+                </a:solidFill>
+                <a:latin typeface="Source Sans Pro" panose="020B0503030403020204" pitchFamily="34" charset="0"/>
+              </a:rPr>
+              <a:t>This report reflects the results of that joint effort, which has expanded with each edition. The inclusion of new topics, such as the Point Merge, as well as the comparison related to the Curitiba and Lisbon ACCs, shows that even with distinct regional characteristics and operational specificities, benchmarking is not only possible but highly valuable. It broadens mutual understanding and reinforces the feasibility of applying solutions and concepts to the reality of each system.</a:t>
+            </a:r>
+          </a:p>
+          <a:p>
+            <a:pPr algn="just"/>
+            <a:endParaRPr lang="en-GB" i="1" dirty="0">
+              <a:solidFill>
+                <a:srgbClr val="343A40"/>
+              </a:solidFill>
+              <a:latin typeface="Source Sans Pro" panose="020B0503030403020204" pitchFamily="34" charset="0"/>
+            </a:endParaRPr>
+          </a:p>
+          <a:p>
+            <a:pPr algn="just"/>
+            <a:r>
+              <a:rPr lang="en-GB" i="1" dirty="0">
+                <a:solidFill>
+                  <a:srgbClr val="343A40"/>
+                </a:solidFill>
+                <a:latin typeface="Source Sans Pro" panose="020B0503030403020204" pitchFamily="34" charset="0"/>
+              </a:rPr>
+              <a:t>This promising journey highlights the evolution of our air navigation system, driven by performance measurement and continuous dialogue with partners such as EUROCONTROL. It demonstrates that we are on the right path — one guided by cooperation, transparency, and a commitment to continuous improvement.</a:t>
+            </a:r>
+          </a:p>
+          <a:p>
+            <a:pPr algn="just">
+              <a:buNone/>
+            </a:pPr>
+            <a:endParaRPr lang="en-GB" i="1" dirty="0">
+              <a:solidFill>
+                <a:srgbClr val="343A40"/>
+              </a:solidFill>
+              <a:latin typeface="Source Sans Pro" panose="020B0503030403020204" pitchFamily="34" charset="0"/>
+            </a:endParaRPr>
+          </a:p>
+        </p:txBody>
+      </p:sp>
+      <p:sp>
+        <p:nvSpPr>
+          <p:cNvPr id="4" name="TextBox 3">
+            <a:extLst>
+              <a:ext uri="{FF2B5EF4-FFF2-40B4-BE49-F238E27FC236}">
+                <a16:creationId xmlns:a16="http://schemas.microsoft.com/office/drawing/2014/main" id="{96083BE3-8484-B997-773B-BF81A4634E2C}"/>
+              </a:ext>
+            </a:extLst>
+          </p:cNvPr>
+          <p:cNvSpPr txBox="1"/>
+          <p:nvPr/>
+        </p:nvSpPr>
+        <p:spPr>
+          <a:xfrm>
+            <a:off x="800194" y="2562208"/>
+            <a:ext cx="2373237" cy="1077218"/>
+          </a:xfrm>
+          <a:prstGeom prst="rect">
+            <a:avLst/>
+          </a:prstGeom>
+          <a:noFill/>
+        </p:spPr>
+        <p:txBody>
+          <a:bodyPr wrap="square">
+            <a:spAutoFit/>
+          </a:bodyPr>
+          <a:lstStyle/>
+          <a:p>
+            <a:pPr algn="ctr"/>
+            <a:r>
+              <a:rPr lang="en-GB" sz="1600" b="1" i="0" dirty="0">
+                <a:solidFill>
+                  <a:srgbClr val="343A40"/>
+                </a:solidFill>
+                <a:effectLst/>
+                <a:latin typeface="Source Sans Pro" panose="020B0503030403020204" pitchFamily="34" charset="0"/>
+              </a:rPr>
+              <a:t>General Maurício </a:t>
+            </a:r>
+            <a:br>
+              <a:rPr lang="en-GB" sz="1600" b="1" i="0" dirty="0">
+                <a:solidFill>
+                  <a:srgbClr val="343A40"/>
+                </a:solidFill>
+                <a:effectLst/>
+                <a:latin typeface="Source Sans Pro" panose="020B0503030403020204" pitchFamily="34" charset="0"/>
+              </a:rPr>
+            </a:br>
+            <a:r>
+              <a:rPr lang="en-GB" sz="1600" b="1" i="0" dirty="0">
+                <a:solidFill>
+                  <a:srgbClr val="343A40"/>
+                </a:solidFill>
+                <a:effectLst/>
+                <a:latin typeface="Source Sans Pro" panose="020B0503030403020204" pitchFamily="34" charset="0"/>
+              </a:rPr>
+              <a:t>Augusto Silveira </a:t>
+            </a:r>
+            <a:br>
+              <a:rPr lang="en-GB" sz="1600" b="1" i="0" dirty="0">
+                <a:solidFill>
+                  <a:srgbClr val="343A40"/>
+                </a:solidFill>
+                <a:effectLst/>
+                <a:latin typeface="Source Sans Pro" panose="020B0503030403020204" pitchFamily="34" charset="0"/>
+              </a:rPr>
+            </a:br>
+            <a:r>
+              <a:rPr lang="en-GB" sz="1600" b="1" i="0" dirty="0">
+                <a:solidFill>
+                  <a:srgbClr val="343A40"/>
+                </a:solidFill>
+                <a:effectLst/>
+                <a:latin typeface="Source Sans Pro" panose="020B0503030403020204" pitchFamily="34" charset="0"/>
+              </a:rPr>
+              <a:t>de Medeiros</a:t>
+            </a:r>
+            <a:endParaRPr lang="en-GB" sz="1600" b="0" i="0" dirty="0">
+              <a:solidFill>
+                <a:srgbClr val="343A40"/>
+              </a:solidFill>
+              <a:effectLst/>
+              <a:latin typeface="Source Sans Pro" panose="020B0503030403020204" pitchFamily="34" charset="0"/>
+            </a:endParaRPr>
+          </a:p>
+          <a:p>
+            <a:pPr algn="ctr"/>
+            <a:r>
+              <a:rPr lang="en-GB" sz="1600" b="0" i="1" dirty="0">
+                <a:solidFill>
+                  <a:srgbClr val="343A40"/>
+                </a:solidFill>
+                <a:effectLst/>
+                <a:latin typeface="Source Sans Pro" panose="020B0503030403020204" pitchFamily="34" charset="0"/>
+              </a:rPr>
+              <a:t>Director General of DECEA</a:t>
+            </a:r>
+            <a:endParaRPr lang="en-GB" sz="1600" b="0" i="0" dirty="0">
+              <a:solidFill>
+                <a:srgbClr val="343A40"/>
+              </a:solidFill>
+              <a:effectLst/>
+              <a:latin typeface="Source Sans Pro" panose="020B0503030403020204" pitchFamily="34" charset="0"/>
+            </a:endParaRPr>
+          </a:p>
+        </p:txBody>
+      </p:sp>
+      <p:pic>
+        <p:nvPicPr>
+          <p:cNvPr id="5" name="Picture 4" descr="A person in a suit and tie&#10;&#10;Description automatically generated">
+            <a:extLst>
+              <a:ext uri="{FF2B5EF4-FFF2-40B4-BE49-F238E27FC236}">
+                <a16:creationId xmlns:a16="http://schemas.microsoft.com/office/drawing/2014/main" id="{CB0F0B36-5EAC-9494-497A-D53B590511F0}"/>
+              </a:ext>
+            </a:extLst>
+          </p:cNvPr>
+          <p:cNvPicPr>
+            <a:picLocks noChangeAspect="1"/>
+          </p:cNvPicPr>
+          <p:nvPr/>
+        </p:nvPicPr>
+        <p:blipFill>
+          <a:blip r:embed="rId2"/>
+          <a:stretch>
+            <a:fillRect/>
+          </a:stretch>
+        </p:blipFill>
+        <p:spPr>
+          <a:xfrm>
+            <a:off x="1144969" y="3812237"/>
+            <a:ext cx="1683689" cy="1683689"/>
+          </a:xfrm>
+          <a:prstGeom prst="rect">
+            <a:avLst/>
+          </a:prstGeom>
+        </p:spPr>
+      </p:pic>
+      <p:sp>
+        <p:nvSpPr>
+          <p:cNvPr id="6" name="TextBox 5">
+            <a:extLst>
+              <a:ext uri="{FF2B5EF4-FFF2-40B4-BE49-F238E27FC236}">
+                <a16:creationId xmlns:a16="http://schemas.microsoft.com/office/drawing/2014/main" id="{D78F8E69-48EC-66F3-3794-B6C16E1CF058}"/>
+              </a:ext>
+            </a:extLst>
+          </p:cNvPr>
+          <p:cNvSpPr txBox="1"/>
+          <p:nvPr/>
+        </p:nvSpPr>
+        <p:spPr>
+          <a:xfrm>
+            <a:off x="-9135" y="5615831"/>
+            <a:ext cx="4215549" cy="1077218"/>
+          </a:xfrm>
+          <a:prstGeom prst="rect">
+            <a:avLst/>
+          </a:prstGeom>
+          <a:noFill/>
+        </p:spPr>
+        <p:txBody>
+          <a:bodyPr wrap="square">
+            <a:spAutoFit/>
+          </a:bodyPr>
+          <a:lstStyle/>
+          <a:p>
+            <a:pPr algn="ctr"/>
+            <a:r>
+              <a:rPr lang="en-GB" sz="1600" b="1" i="0" dirty="0">
+                <a:solidFill>
+                  <a:srgbClr val="343A40"/>
+                </a:solidFill>
+                <a:effectLst/>
+                <a:latin typeface="Source Sans Pro" panose="020B0503030403020204" pitchFamily="34" charset="0"/>
+              </a:rPr>
+              <a:t>Dr Peter Whysall</a:t>
+            </a:r>
+            <a:endParaRPr lang="en-GB" sz="1600" b="0" i="0" dirty="0">
+              <a:solidFill>
+                <a:srgbClr val="343A40"/>
+              </a:solidFill>
+              <a:effectLst/>
+              <a:latin typeface="Source Sans Pro" panose="020B0503030403020204" pitchFamily="34" charset="0"/>
+            </a:endParaRPr>
+          </a:p>
+          <a:p>
+            <a:pPr algn="ctr"/>
+            <a:r>
+              <a:rPr lang="en-GB" sz="1600" b="0" i="1" dirty="0">
+                <a:solidFill>
+                  <a:srgbClr val="343A40"/>
+                </a:solidFill>
+                <a:effectLst/>
+                <a:latin typeface="Source Sans Pro" panose="020B0503030403020204" pitchFamily="34" charset="0"/>
+              </a:rPr>
+              <a:t>Chairman of the </a:t>
+            </a:r>
+            <a:br>
+              <a:rPr lang="en-GB" sz="1600" b="0" i="1" dirty="0">
+                <a:solidFill>
+                  <a:srgbClr val="343A40"/>
+                </a:solidFill>
+                <a:effectLst/>
+                <a:latin typeface="Source Sans Pro" panose="020B0503030403020204" pitchFamily="34" charset="0"/>
+              </a:rPr>
+            </a:br>
+            <a:r>
+              <a:rPr lang="en-GB" sz="1600" b="0" i="1" dirty="0">
+                <a:solidFill>
+                  <a:srgbClr val="343A40"/>
+                </a:solidFill>
+                <a:effectLst/>
+                <a:latin typeface="Source Sans Pro" panose="020B0503030403020204" pitchFamily="34" charset="0"/>
+              </a:rPr>
+              <a:t>Performance </a:t>
+            </a:r>
+            <a:br>
+              <a:rPr lang="en-GB" sz="1600" b="0" i="1" dirty="0">
+                <a:solidFill>
+                  <a:srgbClr val="343A40"/>
+                </a:solidFill>
+                <a:effectLst/>
+                <a:latin typeface="Source Sans Pro" panose="020B0503030403020204" pitchFamily="34" charset="0"/>
+              </a:rPr>
+            </a:br>
+            <a:r>
+              <a:rPr lang="en-GB" sz="1600" b="0" i="1" dirty="0">
+                <a:solidFill>
+                  <a:srgbClr val="343A40"/>
+                </a:solidFill>
+                <a:effectLst/>
+                <a:latin typeface="Source Sans Pro" panose="020B0503030403020204" pitchFamily="34" charset="0"/>
+              </a:rPr>
+              <a:t>Review Commission</a:t>
+            </a:r>
+            <a:endParaRPr lang="en-GB" sz="1600" b="0" i="0" dirty="0">
+              <a:solidFill>
+                <a:srgbClr val="343A40"/>
+              </a:solidFill>
+              <a:effectLst/>
+              <a:latin typeface="Source Sans Pro" panose="020B0503030403020204" pitchFamily="34" charset="0"/>
+            </a:endParaRPr>
+          </a:p>
+        </p:txBody>
+      </p:sp>
+      <p:pic>
+        <p:nvPicPr>
+          <p:cNvPr id="7" name="Picture 6">
+            <a:extLst>
+              <a:ext uri="{FF2B5EF4-FFF2-40B4-BE49-F238E27FC236}">
+                <a16:creationId xmlns:a16="http://schemas.microsoft.com/office/drawing/2014/main" id="{05F9B8F4-7C0B-56F0-0312-F1BE84625800}"/>
+              </a:ext>
+            </a:extLst>
+          </p:cNvPr>
+          <p:cNvPicPr>
+            <a:picLocks noChangeAspect="1"/>
+          </p:cNvPicPr>
+          <p:nvPr/>
+        </p:nvPicPr>
+        <p:blipFill>
+          <a:blip r:embed="rId3"/>
+          <a:stretch>
+            <a:fillRect/>
+          </a:stretch>
+        </p:blipFill>
+        <p:spPr>
+          <a:xfrm>
+            <a:off x="1095549" y="779677"/>
+            <a:ext cx="1782531" cy="1782531"/>
+          </a:xfrm>
+          <a:prstGeom prst="rect">
+            <a:avLst/>
+          </a:prstGeom>
+        </p:spPr>
+      </p:pic>
+    </p:spTree>
+    <p:extLst>
+      <p:ext uri="{BB962C8B-B14F-4D97-AF65-F5344CB8AC3E}">
+        <p14:creationId xmlns:p14="http://schemas.microsoft.com/office/powerpoint/2010/main" val="2559786601"/>
+      </p:ext>
+    </p:extLst>
+  </p:cSld>
+  <p:clrMapOvr>
+    <a:masterClrMapping/>
+  </p:clrMapOvr>
+</p:sld>
+</file>
+
+<file path=ppt/slides/slide3.xml><?xml version="1.0" encoding="utf-8"?>
 <p:sld xmlns:a="http://schemas.openxmlformats.org/drawingml/2006/main" xmlns:r="http://schemas.openxmlformats.org/officeDocument/2006/relationships" xmlns:p="http://schemas.openxmlformats.org/presentationml/2006/main">
   <p:cSld>
     <p:spTree>

</xml_diff>

<commit_message>
post blackout - start of final push
</commit_message>
<xml_diff>
--- a/figures/__figures-handmade.pptx
+++ b/figures/__figures-handmade.pptx
@@ -8,6 +8,7 @@
     <p:sldId id="256" r:id="rId2"/>
     <p:sldId id="258" r:id="rId3"/>
     <p:sldId id="257" r:id="rId4"/>
+    <p:sldId id="259" r:id="rId5"/>
   </p:sldIdLst>
   <p:sldSz cx="12192000" cy="6858000"/>
   <p:notesSz cx="6858000" cy="9144000"/>
@@ -261,7 +262,7 @@
           <a:p>
             <a:fld id="{B7CFA484-72E8-A442-BADE-A5888C8D7710}" type="datetimeFigureOut">
               <a:rPr lang="en-GB" smtClean="0"/>
-              <a:t>25/04/2025</a:t>
+              <a:t>29/04/2025</a:t>
             </a:fld>
             <a:endParaRPr lang="en-GB"/>
           </a:p>
@@ -459,7 +460,7 @@
           <a:p>
             <a:fld id="{B7CFA484-72E8-A442-BADE-A5888C8D7710}" type="datetimeFigureOut">
               <a:rPr lang="en-GB" smtClean="0"/>
-              <a:t>25/04/2025</a:t>
+              <a:t>29/04/2025</a:t>
             </a:fld>
             <a:endParaRPr lang="en-GB"/>
           </a:p>
@@ -667,7 +668,7 @@
           <a:p>
             <a:fld id="{B7CFA484-72E8-A442-BADE-A5888C8D7710}" type="datetimeFigureOut">
               <a:rPr lang="en-GB" smtClean="0"/>
-              <a:t>25/04/2025</a:t>
+              <a:t>29/04/2025</a:t>
             </a:fld>
             <a:endParaRPr lang="en-GB"/>
           </a:p>
@@ -865,7 +866,7 @@
           <a:p>
             <a:fld id="{B7CFA484-72E8-A442-BADE-A5888C8D7710}" type="datetimeFigureOut">
               <a:rPr lang="en-GB" smtClean="0"/>
-              <a:t>25/04/2025</a:t>
+              <a:t>29/04/2025</a:t>
             </a:fld>
             <a:endParaRPr lang="en-GB"/>
           </a:p>
@@ -1140,7 +1141,7 @@
           <a:p>
             <a:fld id="{B7CFA484-72E8-A442-BADE-A5888C8D7710}" type="datetimeFigureOut">
               <a:rPr lang="en-GB" smtClean="0"/>
-              <a:t>25/04/2025</a:t>
+              <a:t>29/04/2025</a:t>
             </a:fld>
             <a:endParaRPr lang="en-GB"/>
           </a:p>
@@ -1405,7 +1406,7 @@
           <a:p>
             <a:fld id="{B7CFA484-72E8-A442-BADE-A5888C8D7710}" type="datetimeFigureOut">
               <a:rPr lang="en-GB" smtClean="0"/>
-              <a:t>25/04/2025</a:t>
+              <a:t>29/04/2025</a:t>
             </a:fld>
             <a:endParaRPr lang="en-GB"/>
           </a:p>
@@ -1817,7 +1818,7 @@
           <a:p>
             <a:fld id="{B7CFA484-72E8-A442-BADE-A5888C8D7710}" type="datetimeFigureOut">
               <a:rPr lang="en-GB" smtClean="0"/>
-              <a:t>25/04/2025</a:t>
+              <a:t>29/04/2025</a:t>
             </a:fld>
             <a:endParaRPr lang="en-GB"/>
           </a:p>
@@ -1958,7 +1959,7 @@
           <a:p>
             <a:fld id="{B7CFA484-72E8-A442-BADE-A5888C8D7710}" type="datetimeFigureOut">
               <a:rPr lang="en-GB" smtClean="0"/>
-              <a:t>25/04/2025</a:t>
+              <a:t>29/04/2025</a:t>
             </a:fld>
             <a:endParaRPr lang="en-GB"/>
           </a:p>
@@ -2071,7 +2072,7 @@
           <a:p>
             <a:fld id="{B7CFA484-72E8-A442-BADE-A5888C8D7710}" type="datetimeFigureOut">
               <a:rPr lang="en-GB" smtClean="0"/>
-              <a:t>25/04/2025</a:t>
+              <a:t>29/04/2025</a:t>
             </a:fld>
             <a:endParaRPr lang="en-GB"/>
           </a:p>
@@ -2382,7 +2383,7 @@
           <a:p>
             <a:fld id="{B7CFA484-72E8-A442-BADE-A5888C8D7710}" type="datetimeFigureOut">
               <a:rPr lang="en-GB" smtClean="0"/>
-              <a:t>25/04/2025</a:t>
+              <a:t>29/04/2025</a:t>
             </a:fld>
             <a:endParaRPr lang="en-GB"/>
           </a:p>
@@ -2670,7 +2671,7 @@
           <a:p>
             <a:fld id="{B7CFA484-72E8-A442-BADE-A5888C8D7710}" type="datetimeFigureOut">
               <a:rPr lang="en-GB" smtClean="0"/>
-              <a:t>25/04/2025</a:t>
+              <a:t>29/04/2025</a:t>
             </a:fld>
             <a:endParaRPr lang="en-GB"/>
           </a:p>
@@ -2911,7 +2912,7 @@
           <a:p>
             <a:fld id="{B7CFA484-72E8-A442-BADE-A5888C8D7710}" type="datetimeFigureOut">
               <a:rPr lang="en-GB" smtClean="0"/>
-              <a:t>25/04/2025</a:t>
+              <a:t>29/04/2025</a:t>
             </a:fld>
             <a:endParaRPr lang="en-GB"/>
           </a:p>
@@ -5980,6 +5981,66 @@
     <p:extLst>
       <p:ext uri="{BB962C8B-B14F-4D97-AF65-F5344CB8AC3E}">
         <p14:creationId xmlns:p14="http://schemas.microsoft.com/office/powerpoint/2010/main" val="272468446"/>
+      </p:ext>
+    </p:extLst>
+  </p:cSld>
+  <p:clrMapOvr>
+    <a:masterClrMapping/>
+  </p:clrMapOvr>
+</p:sld>
+</file>
+
+<file path=ppt/slides/slide4.xml><?xml version="1.0" encoding="utf-8"?>
+<p:sld xmlns:a="http://schemas.openxmlformats.org/drawingml/2006/main" xmlns:r="http://schemas.openxmlformats.org/officeDocument/2006/relationships" xmlns:p="http://schemas.openxmlformats.org/presentationml/2006/main">
+  <p:cSld>
+    <p:spTree>
+      <p:nvGrpSpPr>
+        <p:cNvPr id="1" name=""/>
+        <p:cNvGrpSpPr/>
+        <p:nvPr/>
+      </p:nvGrpSpPr>
+      <p:grpSpPr>
+        <a:xfrm>
+          <a:off x="0" y="0"/>
+          <a:ext cx="0" cy="0"/>
+          <a:chOff x="0" y="0"/>
+          <a:chExt cx="0" cy="0"/>
+        </a:xfrm>
+      </p:grpSpPr>
+      <p:pic>
+        <p:nvPicPr>
+          <p:cNvPr id="3" name="Picture 2" descr="A map of europe and europe&#10;&#10;AI-generated content may be incorrect.">
+            <a:extLst>
+              <a:ext uri="{FF2B5EF4-FFF2-40B4-BE49-F238E27FC236}">
+                <a16:creationId xmlns:a16="http://schemas.microsoft.com/office/drawing/2014/main" id="{5416C9DC-723B-E51B-6656-1C635CE838D4}"/>
+              </a:ext>
+            </a:extLst>
+          </p:cNvPr>
+          <p:cNvPicPr>
+            <a:picLocks noChangeAspect="1"/>
+          </p:cNvPicPr>
+          <p:nvPr/>
+        </p:nvPicPr>
+        <p:blipFill>
+          <a:blip r:embed="rId2"/>
+          <a:stretch>
+            <a:fillRect/>
+          </a:stretch>
+        </p:blipFill>
+        <p:spPr>
+          <a:xfrm>
+            <a:off x="1553027" y="805530"/>
+            <a:ext cx="8501621" cy="5246940"/>
+          </a:xfrm>
+          <a:prstGeom prst="rect">
+            <a:avLst/>
+          </a:prstGeom>
+        </p:spPr>
+      </p:pic>
+    </p:spTree>
+    <p:extLst>
+      <p:ext uri="{BB962C8B-B14F-4D97-AF65-F5344CB8AC3E}">
+        <p14:creationId xmlns:p14="http://schemas.microsoft.com/office/powerpoint/2010/main" val="647282942"/>
       </p:ext>
     </p:extLst>
   </p:cSld>

</xml_diff>